<commit_message>
Team MM deck: keep the official template layout unchanged
Fill the template's own title and content placeholders in place instead
of moving or removing them; all new shapes sit inside the content area.

Co-Authored-By: Claude Opus 5.5 <noreply@anthropic.com>
Claude-Session: https://claude.ai/code/session_01KSZ4mJfYWy31b5hWc3yBC3
</commit_message>
<xml_diff>
--- a/pulseqos/slides/Team MM_Case Study 3.pptx
+++ b/pulseqos/slides/Team MM_Case Study 3.pptx
@@ -125,7 +125,7 @@
           <a:lstStyle/>
           <a:p>
             <a:r>
-              <a:rPr sz="900" b="1">
+              <a:rPr sz="850" b="1">
                 <a:solidFill>
                   <a:srgbClr val="0B2E4F"/>
                 </a:solidFill>
@@ -152,7 +152,7 @@
               <c:strCache>
                 <c:ptCount val="1"/>
                 <c:pt idx="0">
-                  <c:v>p95 call-probe delay (ms)</c:v>
+                  <c:v>95th percentile ping delay (ms)</c:v>
                 </c:pt>
               </c:strCache>
             </c:strRef>
@@ -210,7 +210,7 @@
             <a:lstStyle/>
             <a:p>
               <a:pPr>
-                <a:defRPr sz="1000" b="1"/>
+                <a:defRPr sz="900" b="1"/>
               </a:pPr>
             </a:p>
           </c:txPr>
@@ -247,7 +247,7 @@
           <a:lstStyle/>
           <a:p>
             <a:pPr>
-              <a:defRPr sz="900"/>
+              <a:defRPr sz="800"/>
             </a:pPr>
           </a:p>
         </c:txPr>
@@ -6634,15 +6634,15 @@
         </p:nvSpPr>
         <p:spPr>
           <a:xfrm>
-            <a:off x="1371600" y="1917655"/>
-            <a:ext cx="9445752" cy="606024"/>
+            <a:off x="4623106" y="1917655"/>
+            <a:ext cx="2945788" cy="606024"/>
           </a:xfrm>
           <a:prstGeom prst="rect">
             <a:avLst/>
           </a:prstGeom>
         </p:spPr>
         <p:txBody>
-          <a:bodyPr vert="horz" lIns="91440" tIns="45720" rIns="91440" bIns="45720" rtlCol="0" anchor="b">
+          <a:bodyPr vert="horz" lIns="91440" tIns="45720" rIns="91440" bIns="45720" rtlCol="0" anchor="b" wrap="none">
             <a:noAutofit/>
           </a:bodyPr>
           <a:lstStyle>
@@ -6803,6 +6803,52 @@
       </p:grpSpPr>
       <p:sp>
         <p:nvSpPr>
+          <p:cNvPr id="8" name="Rectangle 7"/>
+          <p:cNvSpPr/>
+          <p:nvPr/>
+        </p:nvSpPr>
+        <p:spPr>
+          <a:xfrm>
+            <a:off x="1017714" y="5813784"/>
+            <a:ext cx="6355080" cy="896112"/>
+          </a:xfrm>
+          <a:prstGeom prst="rect">
+            <a:avLst/>
+          </a:prstGeom>
+          <a:solidFill>
+            <a:srgbClr val="FFFFFF"/>
+          </a:solidFill>
+          <a:ln w="9525">
+            <a:solidFill>
+              <a:srgbClr val="008CC8"/>
+            </a:solidFill>
+          </a:ln>
+          <a:effectLst/>
+        </p:spPr>
+        <p:style>
+          <a:lnRef idx="1">
+            <a:schemeClr val="accent1"/>
+          </a:lnRef>
+          <a:fillRef idx="3">
+            <a:schemeClr val="accent1"/>
+          </a:fillRef>
+          <a:effectRef idx="2">
+            <a:schemeClr val="accent1"/>
+          </a:effectRef>
+          <a:fontRef idx="minor">
+            <a:schemeClr val="lt1"/>
+          </a:fontRef>
+        </p:style>
+        <p:txBody>
+          <a:bodyPr rtlCol="0" anchor="ctr"/>
+          <a:lstStyle/>
+          <a:p>
+            <a:pPr algn="ctr"/>
+          </a:p>
+        </p:txBody>
+      </p:sp>
+      <p:sp>
+        <p:nvSpPr>
           <p:cNvPr id="2" name="Title 1">
             <a:extLst>
               <a:ext uri="{FF2B5EF4-FFF2-40B4-BE49-F238E27FC236}">
@@ -6819,45 +6865,177 @@
         </p:nvSpPr>
         <p:spPr>
           <a:xfrm>
-            <a:off x="2468880" y="73152"/>
-            <a:ext cx="7315200" cy="658368"/>
-          </a:xfrm>
-        </p:spPr>
-        <p:txBody>
-          <a:bodyPr wrap="square" anchor="ctr" lIns="54864" rIns="54864" tIns="27432" bIns="27432"/>
-          <a:lstStyle/>
-          <a:p>
-            <a:pPr algn="l"/>
-            <a:r>
-              <a:rPr sz="2000" b="1">
+            <a:off x="1017714" y="898058"/>
+            <a:ext cx="10515600" cy="1325563"/>
+          </a:xfrm>
+        </p:spPr>
+        <p:txBody>
+          <a:bodyPr/>
+          <a:lstStyle/>
+          <a:p>
+            <a:r>
+              <a:t>PulseQoS: Adaptive Home QoS</a:t>
+            </a:r>
+          </a:p>
+          <a:p>
+            <a:r>
+              <a:rPr sz="1400"/>
+              <a:t>The call never notices the download. An adaptive QoS controller built on Linux tc and CAKE, with no payload inspection.</a:t>
+            </a:r>
+          </a:p>
+        </p:txBody>
+      </p:sp>
+      <p:sp>
+        <p:nvSpPr>
+          <p:cNvPr id="3" name="Content Placeholder 2">
+            <a:extLst>
+              <a:ext uri="{FF2B5EF4-FFF2-40B4-BE49-F238E27FC236}">
+                <a16:creationId xmlns:a16="http://schemas.microsoft.com/office/drawing/2014/main" id="{59CF1BD9-4BA1-4C00-F20D-6F87E11B1D5B}"/>
+              </a:ext>
+            </a:extLst>
+          </p:cNvPr>
+          <p:cNvSpPr>
+            <a:spLocks noGrp="1"/>
+          </p:cNvSpPr>
+          <p:nvPr>
+            <p:ph idx="1"/>
+          </p:nvPr>
+        </p:nvSpPr>
+        <p:spPr>
+          <a:xfrm>
+            <a:off x="1017714" y="2358558"/>
+            <a:ext cx="10515600" cy="4351338"/>
+          </a:xfrm>
+        </p:spPr>
+        <p:txBody>
+          <a:bodyPr wrap="square" anchor="b" lIns="73152" rIns="4233672" tIns="27432" bIns="54864"/>
+          <a:lstStyle/>
+          <a:p>
+            <a:pPr algn="l" marL="0" indent="0">
+              <a:buNone/>
+              <a:spcBef>
+                <a:spcPts val="0"/>
+              </a:spcBef>
+              <a:spcAft>
+                <a:spcPts val="100"/>
+              </a:spcAft>
+            </a:pPr>
+            <a:r>
+              <a:rPr sz="850" b="1">
                 <a:solidFill>
                   <a:srgbClr val="008CC8"/>
                 </a:solidFill>
-                <a:latin typeface="Calibri"/>
               </a:rPr>
-              <a:t>PulseQoS: </a:t>
-            </a:r>
-            <a:r>
-              <a:rPr sz="2000" b="1">
+              <a:t>Key design decisions</a:t>
+            </a:r>
+            <a:endParaRPr lang="en-IN" dirty="0"/>
+          </a:p>
+          <a:p>
+            <a:pPr algn="l" marL="0" indent="0">
+              <a:buNone/>
+              <a:spcBef>
+                <a:spcPts val="0"/>
+              </a:spcBef>
+              <a:spcAft>
+                <a:spcPts val="100"/>
+              </a:spcAft>
+            </a:pPr>
+            <a:r>
+              <a:rPr sz="850" b="1">
                 <a:solidFill>
                   <a:srgbClr val="0B2E4F"/>
                 </a:solidFill>
-                <a:latin typeface="Calibri"/>
               </a:rPr>
-              <a:t>the call never notices the download</a:t>
-            </a:r>
-            <a:endParaRPr lang="en-IN"/>
-          </a:p>
-          <a:p>
-            <a:pPr algn="l"/>
-            <a:r>
-              <a:rPr sz="1150" b="0">
+              <a:t>Tins: </a:t>
+            </a:r>
+            <a:r>
+              <a:rPr sz="850" b="0">
                 <a:solidFill>
                   <a:srgbClr val="333333"/>
                 </a:solidFill>
-                <a:latin typeface="Calibri"/>
               </a:rPr>
-              <a:t>An adaptive QoS controller for home broadband, built on Linux tc and CAKE. No payload inspection.</a:t>
+              <a:t>call audio and games in Voice, call video in Video (Voice is capped at 25% in diffserv4).</a:t>
+            </a:r>
+          </a:p>
+          <a:p>
+            <a:pPr algn="l" marL="0" indent="0">
+              <a:buNone/>
+              <a:spcBef>
+                <a:spcPts val="0"/>
+              </a:spcBef>
+              <a:spcAft>
+                <a:spcPts val="100"/>
+              </a:spcAft>
+            </a:pPr>
+            <a:r>
+              <a:rPr sz="850" b="1">
+                <a:solidFill>
+                  <a:srgbClr val="0B2E4F"/>
+                </a:solidFill>
+              </a:rPr>
+              <a:t>Trust: </a:t>
+            </a:r>
+            <a:r>
+              <a:rPr sz="850" b="0">
+                <a:solidFill>
+                  <a:srgbClr val="333333"/>
+                </a:solidFill>
+              </a:rPr>
+              <a:t>DSCP from the Internet is cleared, so outside traffic cannot claim priority.</a:t>
+            </a:r>
+          </a:p>
+          <a:p>
+            <a:pPr algn="l" marL="0" indent="0">
+              <a:buNone/>
+              <a:spcBef>
+                <a:spcPts val="0"/>
+              </a:spcBef>
+              <a:spcAft>
+                <a:spcPts val="100"/>
+              </a:spcAft>
+            </a:pPr>
+            <a:r>
+              <a:rPr sz="850" b="1">
+                <a:solidFill>
+                  <a:srgbClr val="0B2E4F"/>
+                </a:solidFill>
+              </a:rPr>
+              <a:t>Two loops: </a:t>
+            </a:r>
+            <a:r>
+              <a:rPr sz="850" b="0">
+                <a:solidFill>
+                  <a:srgbClr val="333333"/>
+                </a:solidFill>
+              </a:rPr>
+              <a:t>a speed drop is handled within a second; policy changes pass a safety check first.</a:t>
+            </a:r>
+          </a:p>
+          <a:p>
+            <a:pPr algn="l" marL="0" indent="0">
+              <a:buNone/>
+              <a:spcBef>
+                <a:spcPts val="0"/>
+              </a:spcBef>
+              <a:spcAft>
+                <a:spcPts val="100"/>
+              </a:spcAft>
+            </a:pPr>
+            <a:r>
+              <a:rPr sz="850" b="1">
+                <a:solidFill>
+                  <a:srgbClr val="0B2E4F"/>
+                </a:solidFill>
+              </a:rPr>
+              <a:t>Privacy: </a:t>
+            </a:r>
+            <a:r>
+              <a:rPr sz="850" b="0">
+                <a:solidFill>
+                  <a:srgbClr val="333333"/>
+                </a:solidFill>
+              </a:rPr>
+              <a:t>no payload or domain logging; the intent API is LAN-only and needs a token.</a:t>
             </a:r>
           </a:p>
         </p:txBody>
@@ -6948,55 +7126,20 @@
       </p:pic>
       <p:sp>
         <p:nvSpPr>
-          <p:cNvPr id="8" name="TextBox 7"/>
-          <p:cNvSpPr txBox="1"/>
-          <p:nvPr/>
-        </p:nvSpPr>
-        <p:spPr>
-          <a:xfrm>
-            <a:off x="274320" y="786384"/>
-            <a:ext cx="6903720" cy="274320"/>
-          </a:xfrm>
-          <a:prstGeom prst="rect">
-            <a:avLst/>
-          </a:prstGeom>
-          <a:noFill/>
-        </p:spPr>
-        <p:txBody>
-          <a:bodyPr wrap="square" anchor="t" lIns="54864" rIns="54864" tIns="27432" bIns="27432">
-            <a:spAutoFit/>
-          </a:bodyPr>
-          <a:lstStyle/>
-          <a:p>
-            <a:pPr algn="l"/>
-            <a:r>
-              <a:rPr sz="1050" b="1">
-                <a:solidFill>
-                  <a:srgbClr val="008CC8"/>
-                </a:solidFill>
-                <a:latin typeface="Calibri"/>
-              </a:rPr>
-              <a:t>System architecture</a:t>
-            </a:r>
-          </a:p>
-        </p:txBody>
-      </p:sp>
-      <p:sp>
-        <p:nvSpPr>
           <p:cNvPr id="9" name="Rectangle 8"/>
           <p:cNvSpPr/>
           <p:nvPr/>
         </p:nvSpPr>
         <p:spPr>
           <a:xfrm>
-            <a:off x="274320" y="1069848"/>
-            <a:ext cx="6903720" cy="566928"/>
+            <a:off x="1017714" y="2358558"/>
+            <a:ext cx="6355080" cy="384048"/>
           </a:xfrm>
           <a:prstGeom prst="rect">
             <a:avLst/>
           </a:prstGeom>
           <a:solidFill>
-            <a:srgbClr val="F4F9FD"/>
+            <a:srgbClr val="F2F8FC"/>
           </a:solidFill>
           <a:ln>
             <a:noFill/>
@@ -7033,8 +7176,8 @@
         </p:nvSpPr>
         <p:spPr>
           <a:xfrm>
-            <a:off x="274320" y="1069848"/>
-            <a:ext cx="804672" cy="566928"/>
+            <a:off x="1017714" y="2358558"/>
+            <a:ext cx="658368" cy="384048"/>
           </a:xfrm>
           <a:prstGeom prst="rect">
             <a:avLst/>
@@ -7062,16 +7205,15 @@
           </a:fontRef>
         </p:style>
         <p:txBody>
-          <a:bodyPr rtlCol="0" anchor="ctr" wrap="square" lIns="54864" rIns="54864" tIns="27432" bIns="27432"/>
+          <a:bodyPr rtlCol="0" anchor="ctr" wrap="square" lIns="18288" rIns="18288" tIns="27432" bIns="27432"/>
           <a:lstStyle/>
           <a:p>
             <a:pPr algn="ctr"/>
             <a:r>
-              <a:rPr sz="850" b="1">
+              <a:rPr sz="700" b="1">
                 <a:solidFill>
                   <a:srgbClr val="FFFFFF"/>
                 </a:solidFill>
-                <a:latin typeface="Calibri"/>
               </a:rPr>
               <a:t>UI</a:t>
             </a:r>
@@ -7086,14 +7228,14 @@
         </p:nvSpPr>
         <p:spPr>
           <a:xfrm>
-            <a:off x="274320" y="1691640"/>
-            <a:ext cx="6903720" cy="1188720"/>
+            <a:off x="1017714" y="2970904"/>
+            <a:ext cx="6355080" cy="841248"/>
           </a:xfrm>
           <a:prstGeom prst="rect">
             <a:avLst/>
           </a:prstGeom>
           <a:solidFill>
-            <a:srgbClr val="F4F9FD"/>
+            <a:srgbClr val="F2F8FC"/>
           </a:solidFill>
           <a:ln>
             <a:noFill/>
@@ -7130,8 +7272,8 @@
         </p:nvSpPr>
         <p:spPr>
           <a:xfrm>
-            <a:off x="274320" y="1691640"/>
-            <a:ext cx="804672" cy="1188720"/>
+            <a:off x="1017714" y="2970904"/>
+            <a:ext cx="658368" cy="841248"/>
           </a:xfrm>
           <a:prstGeom prst="rect">
             <a:avLst/>
@@ -7159,16 +7301,15 @@
           </a:fontRef>
         </p:style>
         <p:txBody>
-          <a:bodyPr rtlCol="0" anchor="ctr" wrap="square" lIns="54864" rIns="54864" tIns="27432" bIns="27432"/>
+          <a:bodyPr rtlCol="0" anchor="ctr" wrap="square" lIns="18288" rIns="18288" tIns="27432" bIns="27432"/>
           <a:lstStyle/>
           <a:p>
             <a:pPr algn="ctr"/>
             <a:r>
-              <a:rPr sz="850" b="1">
+              <a:rPr sz="700" b="1">
                 <a:solidFill>
                   <a:srgbClr val="FFFFFF"/>
                 </a:solidFill>
-                <a:latin typeface="Calibri"/>
               </a:rPr>
               <a:t>ANALYTICS</a:t>
             </a:r>
@@ -7176,11 +7317,10 @@
           <a:p>
             <a:pPr algn="ctr"/>
             <a:r>
-              <a:rPr sz="850" b="1">
+              <a:rPr sz="700" b="1">
                 <a:solidFill>
                   <a:srgbClr val="FFFFFF"/>
                 </a:solidFill>
-                <a:latin typeface="Calibri"/>
               </a:rPr>
               <a:t>&amp; CONTROL</a:t>
             </a:r>
@@ -7195,14 +7335,14 @@
         </p:nvSpPr>
         <p:spPr>
           <a:xfrm>
-            <a:off x="274320" y="2935224"/>
-            <a:ext cx="6903720" cy="475488"/>
+            <a:off x="1017714" y="4040451"/>
+            <a:ext cx="6355080" cy="292608"/>
           </a:xfrm>
           <a:prstGeom prst="rect">
             <a:avLst/>
           </a:prstGeom>
           <a:solidFill>
-            <a:srgbClr val="F4F9FD"/>
+            <a:srgbClr val="F2F8FC"/>
           </a:solidFill>
           <a:ln>
             <a:noFill/>
@@ -7239,8 +7379,8 @@
         </p:nvSpPr>
         <p:spPr>
           <a:xfrm>
-            <a:off x="274320" y="2935224"/>
-            <a:ext cx="804672" cy="475488"/>
+            <a:off x="1017714" y="4040451"/>
+            <a:ext cx="658368" cy="292608"/>
           </a:xfrm>
           <a:prstGeom prst="rect">
             <a:avLst/>
@@ -7268,16 +7408,15 @@
           </a:fontRef>
         </p:style>
         <p:txBody>
-          <a:bodyPr rtlCol="0" anchor="ctr" wrap="square" lIns="54864" rIns="54864" tIns="27432" bIns="27432"/>
+          <a:bodyPr rtlCol="0" anchor="ctr" wrap="square" lIns="18288" rIns="18288" tIns="27432" bIns="27432"/>
           <a:lstStyle/>
           <a:p>
             <a:pPr algn="ctr"/>
             <a:r>
-              <a:rPr sz="850" b="1">
+              <a:rPr sz="700" b="1">
                 <a:solidFill>
                   <a:srgbClr val="FFFFFF"/>
                 </a:solidFill>
-                <a:latin typeface="Calibri"/>
               </a:rPr>
               <a:t>DATA</a:t>
             </a:r>
@@ -7292,14 +7431,14 @@
         </p:nvSpPr>
         <p:spPr>
           <a:xfrm>
-            <a:off x="274320" y="3465576"/>
-            <a:ext cx="6903720" cy="896112"/>
+            <a:off x="1017714" y="4561357"/>
+            <a:ext cx="6355080" cy="566928"/>
           </a:xfrm>
           <a:prstGeom prst="rect">
             <a:avLst/>
           </a:prstGeom>
           <a:solidFill>
-            <a:srgbClr val="F4F9FD"/>
+            <a:srgbClr val="F2F8FC"/>
           </a:solidFill>
           <a:ln>
             <a:noFill/>
@@ -7336,8 +7475,8 @@
         </p:nvSpPr>
         <p:spPr>
           <a:xfrm>
-            <a:off x="274320" y="3465576"/>
-            <a:ext cx="804672" cy="896112"/>
+            <a:off x="1017714" y="4561357"/>
+            <a:ext cx="658368" cy="566928"/>
           </a:xfrm>
           <a:prstGeom prst="rect">
             <a:avLst/>
@@ -7365,30 +7504,17 @@
           </a:fontRef>
         </p:style>
         <p:txBody>
-          <a:bodyPr rtlCol="0" anchor="ctr" wrap="square" lIns="54864" rIns="54864" tIns="27432" bIns="27432"/>
+          <a:bodyPr rtlCol="0" anchor="ctr" wrap="square" lIns="18288" rIns="18288" tIns="27432" bIns="27432"/>
           <a:lstStyle/>
           <a:p>
             <a:pPr algn="ctr"/>
             <a:r>
-              <a:rPr sz="850" b="1">
+              <a:rPr sz="700" b="1">
                 <a:solidFill>
                   <a:srgbClr val="FFFFFF"/>
                 </a:solidFill>
-                <a:latin typeface="Calibri"/>
               </a:rPr>
               <a:t>EDGE</a:t>
-            </a:r>
-          </a:p>
-          <a:p>
-            <a:pPr algn="ctr"/>
-            <a:r>
-              <a:rPr sz="850" b="1">
-                <a:solidFill>
-                  <a:srgbClr val="FFFFFF"/>
-                </a:solidFill>
-                <a:latin typeface="Calibri"/>
-              </a:rPr>
-              <a:t>(router)</a:t>
             </a:r>
           </a:p>
         </p:txBody>
@@ -7401,14 +7527,14 @@
         </p:nvSpPr>
         <p:spPr>
           <a:xfrm>
-            <a:off x="274320" y="4416552"/>
-            <a:ext cx="6903720" cy="566928"/>
+            <a:off x="1017714" y="5356584"/>
+            <a:ext cx="6355080" cy="384048"/>
           </a:xfrm>
           <a:prstGeom prst="rect">
             <a:avLst/>
           </a:prstGeom>
           <a:solidFill>
-            <a:srgbClr val="F4F9FD"/>
+            <a:srgbClr val="F2F8FC"/>
           </a:solidFill>
           <a:ln>
             <a:noFill/>
@@ -7445,8 +7571,8 @@
         </p:nvSpPr>
         <p:spPr>
           <a:xfrm>
-            <a:off x="274320" y="4416552"/>
-            <a:ext cx="804672" cy="566928"/>
+            <a:off x="1017714" y="5356584"/>
+            <a:ext cx="658368" cy="384048"/>
           </a:xfrm>
           <a:prstGeom prst="rect">
             <a:avLst/>
@@ -7474,16 +7600,15 @@
           </a:fontRef>
         </p:style>
         <p:txBody>
-          <a:bodyPr rtlCol="0" anchor="ctr" wrap="square" lIns="54864" rIns="54864" tIns="27432" bIns="27432"/>
+          <a:bodyPr rtlCol="0" anchor="ctr" wrap="square" lIns="18288" rIns="18288" tIns="27432" bIns="27432"/>
           <a:lstStyle/>
           <a:p>
             <a:pPr algn="ctr"/>
             <a:r>
-              <a:rPr sz="850" b="1">
+              <a:rPr sz="700" b="1">
                 <a:solidFill>
                   <a:srgbClr val="FFFFFF"/>
                 </a:solidFill>
-                <a:latin typeface="Calibri"/>
               </a:rPr>
               <a:t>DEVICE &amp;</a:t>
             </a:r>
@@ -7491,11 +7616,10 @@
           <a:p>
             <a:pPr algn="ctr"/>
             <a:r>
-              <a:rPr sz="850" b="1">
+              <a:rPr sz="700" b="1">
                 <a:solidFill>
                   <a:srgbClr val="FFFFFF"/>
                 </a:solidFill>
-                <a:latin typeface="Calibri"/>
               </a:rPr>
               <a:t>NETWORK</a:t>
             </a:r>
@@ -7510,18 +7634,18 @@
         </p:nvSpPr>
         <p:spPr>
           <a:xfrm>
-            <a:off x="1170432" y="1115568"/>
-            <a:ext cx="2788920" cy="475488"/>
+            <a:off x="1749234" y="2404278"/>
+            <a:ext cx="2747772" cy="292607"/>
           </a:xfrm>
           <a:prstGeom prst="roundRect">
             <a:avLst>
-              <a:gd name="adj" fmla="val 8000"/>
+              <a:gd name="adj" fmla="val 10000"/>
             </a:avLst>
           </a:prstGeom>
           <a:solidFill>
             <a:srgbClr val="FFFFFF"/>
           </a:solidFill>
-          <a:ln w="12700">
+          <a:ln w="9525">
             <a:solidFill>
               <a:srgbClr val="008CC8"/>
             </a:solidFill>
@@ -7543,16 +7667,15 @@
           </a:fontRef>
         </p:style>
         <p:txBody>
-          <a:bodyPr rtlCol="0" anchor="ctr" wrap="square" lIns="54864" rIns="54864" tIns="27432" bIns="27432"/>
+          <a:bodyPr rtlCol="0" anchor="ctr" wrap="square" lIns="27432" rIns="27432" tIns="27432" bIns="27432"/>
           <a:lstStyle/>
           <a:p>
             <a:pPr algn="ctr"/>
             <a:r>
-              <a:rPr sz="950" b="1">
+              <a:rPr sz="800" b="1">
                 <a:solidFill>
                   <a:srgbClr val="0B2E4F"/>
                 </a:solidFill>
-                <a:latin typeface="Calibri"/>
               </a:rPr>
               <a:t>Focus Mode app / REST API</a:t>
             </a:r>
@@ -7560,11 +7683,10 @@
           <a:p>
             <a:pPr algn="ctr"/>
             <a:r>
-              <a:rPr sz="850" b="0">
+              <a:rPr sz="750" b="0">
                 <a:solidFill>
                   <a:srgbClr val="333333"/>
                 </a:solidFill>
-                <a:latin typeface="Calibri"/>
               </a:rPr>
               <a:t>protect a call for N minutes; auto-protect has undo</a:t>
             </a:r>
@@ -7579,18 +7701,18 @@
         </p:nvSpPr>
         <p:spPr>
           <a:xfrm>
-            <a:off x="4050791" y="1115568"/>
-            <a:ext cx="3035808" cy="475488"/>
+            <a:off x="4588446" y="2404278"/>
+            <a:ext cx="2747772" cy="292607"/>
           </a:xfrm>
           <a:prstGeom prst="roundRect">
             <a:avLst>
-              <a:gd name="adj" fmla="val 8000"/>
+              <a:gd name="adj" fmla="val 10000"/>
             </a:avLst>
           </a:prstGeom>
           <a:solidFill>
             <a:srgbClr val="FFFFFF"/>
           </a:solidFill>
-          <a:ln w="12700">
+          <a:ln w="9525">
             <a:solidFill>
               <a:srgbClr val="008CC8"/>
             </a:solidFill>
@@ -7612,30 +7734,28 @@
           </a:fontRef>
         </p:style>
         <p:txBody>
-          <a:bodyPr rtlCol="0" anchor="ctr" wrap="square" lIns="54864" rIns="54864" tIns="27432" bIns="27432"/>
+          <a:bodyPr rtlCol="0" anchor="ctr" wrap="square" lIns="27432" rIns="27432" tIns="27432" bIns="27432"/>
           <a:lstStyle/>
           <a:p>
             <a:pPr algn="ctr"/>
             <a:r>
-              <a:rPr sz="950" b="1">
+              <a:rPr sz="800" b="1">
                 <a:solidFill>
                   <a:srgbClr val="0B2E4F"/>
                 </a:solidFill>
-                <a:latin typeface="Calibri"/>
               </a:rPr>
-              <a:t>Dashboard + “Why” panel</a:t>
+              <a:t>Dashboard</a:t>
             </a:r>
           </a:p>
           <a:p>
             <a:pPr algn="ctr"/>
             <a:r>
-              <a:rPr sz="850" b="0">
+              <a:rPr sz="750" b="0">
                 <a:solidFill>
                   <a:srgbClr val="333333"/>
                 </a:solidFill>
-                <a:latin typeface="Calibri"/>
               </a:rPr>
-              <a:t>latency, jitter, loss, queue depth, fairness; reason for each change</a:t>
+              <a:t>latency, jitter, loss, queue depth, fairness, reason per change</a:t>
             </a:r>
           </a:p>
         </p:txBody>
@@ -7648,12 +7768,12 @@
         </p:nvSpPr>
         <p:spPr>
           <a:xfrm>
-            <a:off x="1170432" y="1737360"/>
-            <a:ext cx="1417320" cy="1097280"/>
+            <a:off x="1749234" y="3016624"/>
+            <a:ext cx="1328166" cy="749808"/>
           </a:xfrm>
           <a:prstGeom prst="roundRect">
             <a:avLst>
-              <a:gd name="adj" fmla="val 8000"/>
+              <a:gd name="adj" fmla="val 10000"/>
             </a:avLst>
           </a:prstGeom>
           <a:solidFill>
@@ -7679,16 +7799,15 @@
           </a:fontRef>
         </p:style>
         <p:txBody>
-          <a:bodyPr rtlCol="0" anchor="ctr" wrap="square" lIns="54864" rIns="54864" tIns="27432" bIns="27432"/>
+          <a:bodyPr rtlCol="0" anchor="ctr" wrap="square" lIns="27432" rIns="27432" tIns="27432" bIns="27432"/>
           <a:lstStyle/>
           <a:p>
             <a:pPr algn="ctr"/>
             <a:r>
-              <a:rPr sz="900" b="1">
+              <a:rPr sz="750" b="1">
                 <a:solidFill>
                   <a:srgbClr val="F5B400"/>
                 </a:solidFill>
-                <a:latin typeface="Calibri"/>
               </a:rPr>
               <a:t>Rate loop (1 s)</a:t>
             </a:r>
@@ -7696,49 +7815,12 @@
           <a:p>
             <a:pPr algn="ctr"/>
             <a:r>
-              <a:rPr sz="800" b="0">
+              <a:rPr sz="700" b="0">
                 <a:solidFill>
                   <a:srgbClr val="FFFFFF"/>
                 </a:solidFill>
-                <a:latin typeface="Calibri"/>
               </a:rPr>
-              <a:t>capacity estimator</a:t>
-            </a:r>
-          </a:p>
-          <a:p>
-            <a:pPr algn="ctr"/>
-            <a:r>
-              <a:rPr sz="800" b="0">
-                <a:solidFill>
-                  <a:srgbClr val="FFFFFF"/>
-                </a:solidFill>
-                <a:latin typeface="Calibri"/>
-              </a:rPr>
-              <a:t>using one-way delay;</a:t>
-            </a:r>
-          </a:p>
-          <a:p>
-            <a:pPr algn="ctr"/>
-            <a:r>
-              <a:rPr sz="800" b="0">
-                <a:solidFill>
-                  <a:srgbClr val="FFFFFF"/>
-                </a:solidFill>
-                <a:latin typeface="Calibri"/>
-              </a:rPr>
-              <a:t>lowers shaper rate</a:t>
-            </a:r>
-          </a:p>
-          <a:p>
-            <a:pPr algn="ctr"/>
-            <a:r>
-              <a:rPr sz="800" b="0">
-                <a:solidFill>
-                  <a:srgbClr val="FFFFFF"/>
-                </a:solidFill>
-                <a:latin typeface="Calibri"/>
-              </a:rPr>
-              <a:t>immediately</a:t>
+              <a:t>estimates capacity from one-way delay; lowers shaper rate at once</a:t>
             </a:r>
           </a:p>
         </p:txBody>
@@ -7751,12 +7833,12 @@
         </p:nvSpPr>
         <p:spPr>
           <a:xfrm>
-            <a:off x="2670048" y="1737360"/>
-            <a:ext cx="1417320" cy="1097280"/>
+            <a:off x="3168840" y="3016624"/>
+            <a:ext cx="1328166" cy="749808"/>
           </a:xfrm>
           <a:prstGeom prst="roundRect">
             <a:avLst>
-              <a:gd name="adj" fmla="val 8000"/>
+              <a:gd name="adj" fmla="val 10000"/>
             </a:avLst>
           </a:prstGeom>
           <a:solidFill>
@@ -7782,16 +7864,15 @@
           </a:fontRef>
         </p:style>
         <p:txBody>
-          <a:bodyPr rtlCol="0" anchor="ctr" wrap="square" lIns="54864" rIns="54864" tIns="27432" bIns="27432"/>
+          <a:bodyPr rtlCol="0" anchor="ctr" wrap="square" lIns="27432" rIns="27432" tIns="27432" bIns="27432"/>
           <a:lstStyle/>
           <a:p>
             <a:pPr algn="ctr"/>
             <a:r>
-              <a:rPr sz="900" b="1">
+              <a:rPr sz="750" b="1">
                 <a:solidFill>
                   <a:srgbClr val="F5B400"/>
                 </a:solidFill>
-                <a:latin typeface="Calibri"/>
               </a:rPr>
               <a:t>Policy loop (10-30 s)</a:t>
             </a:r>
@@ -7799,49 +7880,12 @@
           <a:p>
             <a:pPr algn="ctr"/>
             <a:r>
-              <a:rPr sz="800" b="0">
+              <a:rPr sz="700" b="0">
                 <a:solidFill>
                   <a:srgbClr val="FFFFFF"/>
                 </a:solidFill>
-                <a:latin typeface="Calibri"/>
               </a:rPr>
-              <a:t>rule-based controller</a:t>
-            </a:r>
-          </a:p>
-          <a:p>
-            <a:pPr algn="ctr"/>
-            <a:r>
-              <a:rPr sz="800" b="0">
-                <a:solidFill>
-                  <a:srgbClr val="FFFFFF"/>
-                </a:solidFill>
-                <a:latin typeface="Calibri"/>
-              </a:rPr>
-              <a:t>fixed set of allowed</a:t>
-            </a:r>
-          </a:p>
-          <a:p>
-            <a:pPr algn="ctr"/>
-            <a:r>
-              <a:rPr sz="800" b="0">
-                <a:solidFill>
-                  <a:srgbClr val="FFFFFF"/>
-                </a:solidFill>
-                <a:latin typeface="Calibri"/>
-              </a:rPr>
-              <a:t>actions, hysteresis,</a:t>
-            </a:r>
-          </a:p>
-          <a:p>
-            <a:pPr algn="ctr"/>
-            <a:r>
-              <a:rPr sz="800" b="0">
-                <a:solidFill>
-                  <a:srgbClr val="FFFFFF"/>
-                </a:solidFill>
-                <a:latin typeface="Calibri"/>
-              </a:rPr>
-              <a:t>minimum hold time</a:t>
+              <a:t>rule-based, fixed set of actions, hysteresis and hold time</a:t>
             </a:r>
           </a:p>
         </p:txBody>
@@ -7854,12 +7898,12 @@
         </p:nvSpPr>
         <p:spPr>
           <a:xfrm>
-            <a:off x="4169663" y="1737360"/>
-            <a:ext cx="1417320" cy="1097280"/>
+            <a:off x="4588446" y="3016624"/>
+            <a:ext cx="1328166" cy="749808"/>
           </a:xfrm>
           <a:prstGeom prst="roundRect">
             <a:avLst>
-              <a:gd name="adj" fmla="val 8000"/>
+              <a:gd name="adj" fmla="val 10000"/>
             </a:avLst>
           </a:prstGeom>
           <a:solidFill>
@@ -7885,16 +7929,15 @@
           </a:fontRef>
         </p:style>
         <p:txBody>
-          <a:bodyPr rtlCol="0" anchor="ctr" wrap="square" lIns="54864" rIns="54864" tIns="27432" bIns="27432"/>
+          <a:bodyPr rtlCol="0" anchor="ctr" wrap="square" lIns="27432" rIns="27432" tIns="27432" bIns="27432"/>
           <a:lstStyle/>
           <a:p>
             <a:pPr algn="ctr"/>
             <a:r>
-              <a:rPr sz="900" b="1">
+              <a:rPr sz="750" b="1">
                 <a:solidFill>
                   <a:srgbClr val="FFFFFF"/>
                 </a:solidFill>
-                <a:latin typeface="Calibri"/>
               </a:rPr>
               <a:t>Link model (ML)</a:t>
             </a:r>
@@ -7902,49 +7945,12 @@
           <a:p>
             <a:pPr algn="ctr"/>
             <a:r>
-              <a:rPr sz="800" b="0">
+              <a:rPr sz="700" b="0">
                 <a:solidFill>
                   <a:srgbClr val="FFFFFF"/>
                 </a:solidFill>
-                <a:latin typeface="Calibri"/>
               </a:rPr>
-              <a:t>predicts call delay</a:t>
-            </a:r>
-          </a:p>
-          <a:p>
-            <a:pPr algn="ctr"/>
-            <a:r>
-              <a:rPr sz="800" b="0">
-                <a:solidFill>
-                  <a:srgbClr val="FFFFFF"/>
-                </a:solidFill>
-                <a:latin typeface="Calibri"/>
-              </a:rPr>
-              <a:t>for each candidate</a:t>
-            </a:r>
-          </a:p>
-          <a:p>
-            <a:pPr algn="ctr"/>
-            <a:r>
-              <a:rPr sz="800" b="0">
-                <a:solidFill>
-                  <a:srgbClr val="FFFFFF"/>
-                </a:solidFill>
-                <a:latin typeface="Calibri"/>
-              </a:rPr>
-              <a:t>action; filters out</a:t>
-            </a:r>
-          </a:p>
-          <a:p>
-            <a:pPr algn="ctr"/>
-            <a:r>
-              <a:rPr sz="800" b="0">
-                <a:solidFill>
-                  <a:srgbClr val="FFFFFF"/>
-                </a:solidFill>
-                <a:latin typeface="Calibri"/>
-              </a:rPr>
-              <a:t>risky ones</a:t>
+              <a:t>predicts call delay per action; filters out risky ones</a:t>
             </a:r>
           </a:p>
         </p:txBody>
@@ -7957,18 +7963,18 @@
         </p:nvSpPr>
         <p:spPr>
           <a:xfrm>
-            <a:off x="5669280" y="1737360"/>
-            <a:ext cx="1417320" cy="1097280"/>
+            <a:off x="6008052" y="3016624"/>
+            <a:ext cx="1328166" cy="749808"/>
           </a:xfrm>
           <a:prstGeom prst="roundRect">
             <a:avLst>
-              <a:gd name="adj" fmla="val 8000"/>
+              <a:gd name="adj" fmla="val 10000"/>
             </a:avLst>
           </a:prstGeom>
           <a:solidFill>
             <a:srgbClr val="FFFFFF"/>
           </a:solidFill>
-          <a:ln w="12700">
+          <a:ln w="9525">
             <a:solidFill>
               <a:srgbClr val="008CC8"/>
             </a:solidFill>
@@ -7990,16 +7996,15 @@
           </a:fontRef>
         </p:style>
         <p:txBody>
-          <a:bodyPr rtlCol="0" anchor="ctr" wrap="square" lIns="54864" rIns="54864" tIns="27432" bIns="27432"/>
+          <a:bodyPr rtlCol="0" anchor="ctr" wrap="square" lIns="27432" rIns="27432" tIns="27432" bIns="27432"/>
           <a:lstStyle/>
           <a:p>
             <a:pPr algn="ctr"/>
             <a:r>
-              <a:rPr sz="900" b="1">
+              <a:rPr sz="750" b="1">
                 <a:solidFill>
                   <a:srgbClr val="0B2E4F"/>
                 </a:solidFill>
-                <a:latin typeface="Calibri"/>
               </a:rPr>
               <a:t>Safety check</a:t>
             </a:r>
@@ -8007,73 +8012,144 @@
           <a:p>
             <a:pPr algn="ctr"/>
             <a:r>
-              <a:rPr sz="800" b="0">
+              <a:rPr sz="700" b="0">
                 <a:solidFill>
                   <a:srgbClr val="333333"/>
                 </a:solidFill>
-                <a:latin typeface="Calibri"/>
               </a:rPr>
-              <a:t>validate, short live</a:t>
-            </a:r>
-          </a:p>
-          <a:p>
-            <a:pPr algn="ctr"/>
-            <a:r>
-              <a:rPr sz="800" b="0">
-                <a:solidFill>
-                  <a:srgbClr val="333333"/>
-                </a:solidFill>
-                <a:latin typeface="Calibri"/>
-              </a:rPr>
-              <a:t>trial, keep or roll</a:t>
-            </a:r>
-          </a:p>
-          <a:p>
-            <a:pPr algn="ctr"/>
-            <a:r>
-              <a:rPr sz="800" b="0">
-                <a:solidFill>
-                  <a:srgbClr val="333333"/>
-                </a:solidFill>
-                <a:latin typeface="Calibri"/>
-              </a:rPr>
-              <a:t>back; watchdog falls</a:t>
-            </a:r>
-          </a:p>
-          <a:p>
-            <a:pPr algn="ctr"/>
-            <a:r>
-              <a:rPr sz="800" b="0">
-                <a:solidFill>
-                  <a:srgbClr val="333333"/>
-                </a:solidFill>
-                <a:latin typeface="Calibri"/>
-              </a:rPr>
-              <a:t>back to plain CAKE</a:t>
-            </a:r>
-          </a:p>
-        </p:txBody>
-      </p:sp>
-      <p:sp>
-        <p:nvSpPr>
-          <p:cNvPr id="25" name="Rounded Rectangle 24"/>
+              <a:t>short live trial, keep or roll back; watchdog falls back to CAKE</a:t>
+            </a:r>
+          </a:p>
+        </p:txBody>
+      </p:sp>
+      <p:cxnSp>
+        <p:nvCxnSpPr>
+          <p:cNvPr id="25" name="Connector 24"/>
+          <p:cNvCxnSpPr/>
+          <p:nvPr/>
+        </p:nvCxnSpPr>
+        <p:spPr>
+          <a:xfrm>
+            <a:off x="3077400" y="3391528"/>
+            <a:ext cx="91440" cy="0"/>
+          </a:xfrm>
+          <a:prstGeom prst="line">
+            <a:avLst/>
+          </a:prstGeom>
+          <a:ln w="15875">
+            <a:solidFill>
+              <a:srgbClr val="0B2E4F"/>
+            </a:solidFill>
+            <a:tailEnd type="triangle"/>
+          </a:ln>
+        </p:spPr>
+        <p:style>
+          <a:lnRef idx="2">
+            <a:schemeClr val="accent1"/>
+          </a:lnRef>
+          <a:fillRef idx="0">
+            <a:schemeClr val="accent1"/>
+          </a:fillRef>
+          <a:effectRef idx="1">
+            <a:schemeClr val="accent1"/>
+          </a:effectRef>
+          <a:fontRef idx="minor">
+            <a:schemeClr val="tx1"/>
+          </a:fontRef>
+        </p:style>
+      </p:cxnSp>
+      <p:cxnSp>
+        <p:nvCxnSpPr>
+          <p:cNvPr id="26" name="Connector 25"/>
+          <p:cNvCxnSpPr/>
+          <p:nvPr/>
+        </p:nvCxnSpPr>
+        <p:spPr>
+          <a:xfrm>
+            <a:off x="4497006" y="3391528"/>
+            <a:ext cx="91440" cy="0"/>
+          </a:xfrm>
+          <a:prstGeom prst="line">
+            <a:avLst/>
+          </a:prstGeom>
+          <a:ln w="15875">
+            <a:solidFill>
+              <a:srgbClr val="0B2E4F"/>
+            </a:solidFill>
+            <a:tailEnd type="triangle"/>
+          </a:ln>
+        </p:spPr>
+        <p:style>
+          <a:lnRef idx="2">
+            <a:schemeClr val="accent1"/>
+          </a:lnRef>
+          <a:fillRef idx="0">
+            <a:schemeClr val="accent1"/>
+          </a:fillRef>
+          <a:effectRef idx="1">
+            <a:schemeClr val="accent1"/>
+          </a:effectRef>
+          <a:fontRef idx="minor">
+            <a:schemeClr val="tx1"/>
+          </a:fontRef>
+        </p:style>
+      </p:cxnSp>
+      <p:cxnSp>
+        <p:nvCxnSpPr>
+          <p:cNvPr id="27" name="Connector 26"/>
+          <p:cNvCxnSpPr/>
+          <p:nvPr/>
+        </p:nvCxnSpPr>
+        <p:spPr>
+          <a:xfrm>
+            <a:off x="5916612" y="3391528"/>
+            <a:ext cx="91440" cy="0"/>
+          </a:xfrm>
+          <a:prstGeom prst="line">
+            <a:avLst/>
+          </a:prstGeom>
+          <a:ln w="15875">
+            <a:solidFill>
+              <a:srgbClr val="0B2E4F"/>
+            </a:solidFill>
+            <a:tailEnd type="triangle"/>
+          </a:ln>
+        </p:spPr>
+        <p:style>
+          <a:lnRef idx="2">
+            <a:schemeClr val="accent1"/>
+          </a:lnRef>
+          <a:fillRef idx="0">
+            <a:schemeClr val="accent1"/>
+          </a:fillRef>
+          <a:effectRef idx="1">
+            <a:schemeClr val="accent1"/>
+          </a:effectRef>
+          <a:fontRef idx="minor">
+            <a:schemeClr val="tx1"/>
+          </a:fontRef>
+        </p:style>
+      </p:cxnSp>
+      <p:sp>
+        <p:nvSpPr>
+          <p:cNvPr id="28" name="Rounded Rectangle 27"/>
           <p:cNvSpPr/>
           <p:nvPr/>
         </p:nvSpPr>
         <p:spPr>
           <a:xfrm>
-            <a:off x="1170432" y="2971800"/>
-            <a:ext cx="5916168" cy="402336"/>
+            <a:off x="1749234" y="4077027"/>
+            <a:ext cx="5586984" cy="219456"/>
           </a:xfrm>
           <a:prstGeom prst="roundRect">
             <a:avLst>
-              <a:gd name="adj" fmla="val 8000"/>
+              <a:gd name="adj" fmla="val 10000"/>
             </a:avLst>
           </a:prstGeom>
           <a:solidFill>
             <a:srgbClr val="FFFFFF"/>
           </a:solidFill>
-          <a:ln w="12700">
+          <a:ln w="9525">
             <a:solidFill>
               <a:srgbClr val="008CC8"/>
             </a:solidFill>
@@ -8095,48 +8171,35 @@
           </a:fontRef>
         </p:style>
         <p:txBody>
-          <a:bodyPr rtlCol="0" anchor="ctr" wrap="square" lIns="54864" rIns="54864" tIns="27432" bIns="27432"/>
+          <a:bodyPr rtlCol="0" anchor="ctr" wrap="square" lIns="27432" rIns="27432" tIns="27432" bIns="27432"/>
           <a:lstStyle/>
           <a:p>
             <a:pPr algn="ctr"/>
             <a:r>
-              <a:rPr sz="950" b="1">
+              <a:rPr sz="800" b="1">
                 <a:solidFill>
                   <a:srgbClr val="0B2E4F"/>
                 </a:solidFill>
-                <a:latin typeface="Calibri"/>
               </a:rPr>
-              <a:t>Flow table (conntrack), telemetry store, versioned policies, audit log</a:t>
-            </a:r>
-          </a:p>
-          <a:p>
-            <a:pPr algn="ctr"/>
-            <a:r>
-              <a:rPr sz="850" b="0">
-                <a:solidFill>
-                  <a:srgbClr val="333333"/>
-                </a:solidFill>
-                <a:latin typeface="Calibri"/>
-              </a:rPr>
-              <a:t/>
-            </a:r>
-          </a:p>
-        </p:txBody>
-      </p:sp>
-      <p:sp>
-        <p:nvSpPr>
-          <p:cNvPr id="26" name="Rounded Rectangle 25"/>
+              <a:t>Flow table (conntrack), telemetry, versioned policies, audit log</a:t>
+            </a:r>
+          </a:p>
+        </p:txBody>
+      </p:sp>
+      <p:sp>
+        <p:nvSpPr>
+          <p:cNvPr id="29" name="Rounded Rectangle 28"/>
           <p:cNvSpPr/>
           <p:nvPr/>
         </p:nvSpPr>
         <p:spPr>
           <a:xfrm>
-            <a:off x="1170432" y="3511296"/>
-            <a:ext cx="1874519" cy="804672"/>
+            <a:off x="1749234" y="4607077"/>
+            <a:ext cx="1801368" cy="475488"/>
           </a:xfrm>
           <a:prstGeom prst="roundRect">
             <a:avLst>
-              <a:gd name="adj" fmla="val 8000"/>
+              <a:gd name="adj" fmla="val 10000"/>
             </a:avLst>
           </a:prstGeom>
           <a:solidFill>
@@ -8162,16 +8225,15 @@
           </a:fontRef>
         </p:style>
         <p:txBody>
-          <a:bodyPr rtlCol="0" anchor="ctr" wrap="square" lIns="54864" rIns="54864" tIns="27432" bIns="27432"/>
+          <a:bodyPr rtlCol="0" anchor="ctr" wrap="square" lIns="27432" rIns="27432" tIns="27432" bIns="27432"/>
           <a:lstStyle/>
           <a:p>
             <a:pPr algn="ctr"/>
             <a:r>
-              <a:rPr sz="950" b="1">
+              <a:rPr sz="750" b="1">
                 <a:solidFill>
                   <a:srgbClr val="FFFFFF"/>
                 </a:solidFill>
-                <a:latin typeface="Calibri"/>
               </a:rPr>
               <a:t>Flow classifier (ML)</a:t>
             </a:r>
@@ -8179,49 +8241,36 @@
           <a:p>
             <a:pPr algn="ctr"/>
             <a:r>
-              <a:rPr sz="850" b="0">
+              <a:rPr sz="700" b="0">
                 <a:solidFill>
                   <a:srgbClr val="FFFFFF"/>
                 </a:solidFill>
-                <a:latin typeface="Calibri"/>
               </a:rPr>
-              <a:t>packet sizes and timing only;</a:t>
-            </a:r>
-          </a:p>
-          <a:p>
-            <a:pPr algn="ctr"/>
-            <a:r>
-              <a:rPr sz="850" b="0">
-                <a:solidFill>
-                  <a:srgbClr val="FFFFFF"/>
-                </a:solidFill>
-                <a:latin typeface="Calibri"/>
-              </a:rPr>
-              <a:t>unsure flows stay best effort</a:t>
-            </a:r>
-          </a:p>
-        </p:txBody>
-      </p:sp>
-      <p:sp>
-        <p:nvSpPr>
-          <p:cNvPr id="27" name="Rounded Rectangle 26"/>
+              <a:t>packet sizes and timing only; unsure flows stay best effort</a:t>
+            </a:r>
+          </a:p>
+        </p:txBody>
+      </p:sp>
+      <p:sp>
+        <p:nvSpPr>
+          <p:cNvPr id="30" name="Rounded Rectangle 29"/>
           <p:cNvSpPr/>
           <p:nvPr/>
         </p:nvSpPr>
         <p:spPr>
           <a:xfrm>
-            <a:off x="3136391" y="3511296"/>
-            <a:ext cx="1965960" cy="804672"/>
+            <a:off x="3642042" y="4607077"/>
+            <a:ext cx="1801368" cy="475488"/>
           </a:xfrm>
           <a:prstGeom prst="roundRect">
             <a:avLst>
-              <a:gd name="adj" fmla="val 8000"/>
+              <a:gd name="adj" fmla="val 10000"/>
             </a:avLst>
           </a:prstGeom>
           <a:solidFill>
             <a:srgbClr val="FFFFFF"/>
           </a:solidFill>
-          <a:ln w="12700">
+          <a:ln w="9525">
             <a:solidFill>
               <a:srgbClr val="008CC8"/>
             </a:solidFill>
@@ -8243,16 +8292,15 @@
           </a:fontRef>
         </p:style>
         <p:txBody>
-          <a:bodyPr rtlCol="0" anchor="ctr" wrap="square" lIns="54864" rIns="54864" tIns="27432" bIns="27432"/>
+          <a:bodyPr rtlCol="0" anchor="ctr" wrap="square" lIns="27432" rIns="27432" tIns="27432" bIns="27432"/>
           <a:lstStyle/>
           <a:p>
             <a:pPr algn="ctr"/>
             <a:r>
-              <a:rPr sz="950" b="1">
+              <a:rPr sz="750" b="1">
                 <a:solidFill>
                   <a:srgbClr val="0B2E4F"/>
                 </a:solidFill>
-                <a:latin typeface="Calibri"/>
               </a:rPr>
               <a:t>Flow marking</a:t>
             </a:r>
@@ -8260,49 +8308,36 @@
           <a:p>
             <a:pPr algn="ctr"/>
             <a:r>
-              <a:rPr sz="850" b="0">
+              <a:rPr sz="700" b="0">
                 <a:solidFill>
                   <a:srgbClr val="333333"/>
                 </a:solidFill>
-                <a:latin typeface="Calibri"/>
               </a:rPr>
-              <a:t>class stored in conntrack</a:t>
-            </a:r>
-          </a:p>
-          <a:p>
-            <a:pPr algn="ctr"/>
-            <a:r>
-              <a:rPr sz="850" b="0">
-                <a:solidFill>
-                  <a:srgbClr val="333333"/>
-                </a:solidFill>
-                <a:latin typeface="Calibri"/>
-              </a:rPr>
-              <a:t>mark, restored with ctinfo</a:t>
-            </a:r>
-          </a:p>
-        </p:txBody>
-      </p:sp>
-      <p:sp>
-        <p:nvSpPr>
-          <p:cNvPr id="28" name="Rounded Rectangle 27"/>
+              <a:t>class kept in conntrack mark, restored with ctinfo</a:t>
+            </a:r>
+          </a:p>
+        </p:txBody>
+      </p:sp>
+      <p:sp>
+        <p:nvSpPr>
+          <p:cNvPr id="31" name="Rounded Rectangle 30"/>
           <p:cNvSpPr/>
           <p:nvPr/>
         </p:nvSpPr>
         <p:spPr>
           <a:xfrm>
-            <a:off x="5193792" y="3511296"/>
-            <a:ext cx="1892807" cy="804672"/>
+            <a:off x="5534850" y="4607077"/>
+            <a:ext cx="1801368" cy="475488"/>
           </a:xfrm>
           <a:prstGeom prst="roundRect">
             <a:avLst>
-              <a:gd name="adj" fmla="val 8000"/>
+              <a:gd name="adj" fmla="val 10000"/>
             </a:avLst>
           </a:prstGeom>
           <a:solidFill>
             <a:srgbClr val="FFFFFF"/>
           </a:solidFill>
-          <a:ln w="12700">
+          <a:ln w="9525">
             <a:solidFill>
               <a:srgbClr val="008CC8"/>
             </a:solidFill>
@@ -8324,16 +8359,15 @@
           </a:fontRef>
         </p:style>
         <p:txBody>
-          <a:bodyPr rtlCol="0" anchor="ctr" wrap="square" lIns="54864" rIns="54864" tIns="27432" bIns="27432"/>
+          <a:bodyPr rtlCol="0" anchor="ctr" wrap="square" lIns="27432" rIns="27432" tIns="27432" bIns="27432"/>
           <a:lstStyle/>
           <a:p>
             <a:pPr algn="ctr"/>
             <a:r>
-              <a:rPr sz="950" b="1">
+              <a:rPr sz="750" b="1">
                 <a:solidFill>
                   <a:srgbClr val="0B2E4F"/>
                 </a:solidFill>
-                <a:latin typeface="Calibri"/>
               </a:rPr>
               <a:t>Linux tc</a:t>
             </a:r>
@@ -8341,203 +8375,16 @@
           <a:p>
             <a:pPr algn="ctr"/>
             <a:r>
-              <a:rPr sz="850" b="0">
+              <a:rPr sz="700" b="0">
                 <a:solidFill>
                   <a:srgbClr val="333333"/>
                 </a:solidFill>
-                <a:latin typeface="Calibri"/>
               </a:rPr>
-              <a:t>CAKE on WAN and IFB;</a:t>
-            </a:r>
-          </a:p>
-          <a:p>
-            <a:pPr algn="ctr"/>
-            <a:r>
-              <a:rPr sz="850" b="0">
-                <a:solidFill>
-                  <a:srgbClr val="333333"/>
-                </a:solidFill>
-                <a:latin typeface="Calibri"/>
-              </a:rPr>
-              <a:t>HTB variant for hard floors</a:t>
-            </a:r>
-          </a:p>
-        </p:txBody>
-      </p:sp>
-      <p:sp>
-        <p:nvSpPr>
-          <p:cNvPr id="29" name="Rounded Rectangle 28"/>
-          <p:cNvSpPr/>
-          <p:nvPr/>
-        </p:nvSpPr>
-        <p:spPr>
-          <a:xfrm>
-            <a:off x="1170432" y="4462272"/>
-            <a:ext cx="2788920" cy="475488"/>
-          </a:xfrm>
-          <a:prstGeom prst="roundRect">
-            <a:avLst>
-              <a:gd name="adj" fmla="val 8000"/>
-            </a:avLst>
-          </a:prstGeom>
-          <a:solidFill>
-            <a:srgbClr val="FFFFFF"/>
-          </a:solidFill>
-          <a:ln w="12700">
-            <a:solidFill>
-              <a:srgbClr val="008CC8"/>
-            </a:solidFill>
-          </a:ln>
-          <a:effectLst/>
-        </p:spPr>
-        <p:style>
-          <a:lnRef idx="1">
-            <a:schemeClr val="accent1"/>
-          </a:lnRef>
-          <a:fillRef idx="3">
-            <a:schemeClr val="accent1"/>
-          </a:fillRef>
-          <a:effectRef idx="2">
-            <a:schemeClr val="accent1"/>
-          </a:effectRef>
-          <a:fontRef idx="minor">
-            <a:schemeClr val="lt1"/>
-          </a:fontRef>
-        </p:style>
-        <p:txBody>
-          <a:bodyPr rtlCol="0" anchor="ctr" wrap="square" lIns="54864" rIns="54864" tIns="27432" bIns="27432"/>
-          <a:lstStyle/>
-          <a:p>
-            <a:pPr algn="ctr"/>
-            <a:r>
-              <a:rPr sz="950" b="1">
-                <a:solidFill>
-                  <a:srgbClr val="0B2E4F"/>
-                </a:solidFill>
-                <a:latin typeface="Calibri"/>
-              </a:rPr>
-              <a:t>Home devices (emulated)</a:t>
-            </a:r>
-          </a:p>
-          <a:p>
-            <a:pPr algn="ctr"/>
-            <a:r>
-              <a:rPr sz="850" b="0">
-                <a:solidFill>
-                  <a:srgbClr val="333333"/>
-                </a:solidFill>
-                <a:latin typeface="Calibri"/>
-              </a:rPr>
-              <a:t>laptop on a call, console, 3 TVs, a large download</a:t>
-            </a:r>
-          </a:p>
-        </p:txBody>
-      </p:sp>
-      <p:sp>
-        <p:nvSpPr>
-          <p:cNvPr id="30" name="Rounded Rectangle 29"/>
-          <p:cNvSpPr/>
-          <p:nvPr/>
-        </p:nvSpPr>
-        <p:spPr>
-          <a:xfrm>
-            <a:off x="4050791" y="4462272"/>
-            <a:ext cx="3035808" cy="475488"/>
-          </a:xfrm>
-          <a:prstGeom prst="roundRect">
-            <a:avLst>
-              <a:gd name="adj" fmla="val 8000"/>
-            </a:avLst>
-          </a:prstGeom>
-          <a:solidFill>
-            <a:srgbClr val="FFFFFF"/>
-          </a:solidFill>
-          <a:ln w="12700">
-            <a:solidFill>
-              <a:srgbClr val="008CC8"/>
-            </a:solidFill>
-          </a:ln>
-          <a:effectLst/>
-        </p:spPr>
-        <p:style>
-          <a:lnRef idx="1">
-            <a:schemeClr val="accent1"/>
-          </a:lnRef>
-          <a:fillRef idx="3">
-            <a:schemeClr val="accent1"/>
-          </a:fillRef>
-          <a:effectRef idx="2">
-            <a:schemeClr val="accent1"/>
-          </a:effectRef>
-          <a:fontRef idx="minor">
-            <a:schemeClr val="lt1"/>
-          </a:fontRef>
-        </p:style>
-        <p:txBody>
-          <a:bodyPr rtlCol="0" anchor="ctr" wrap="square" lIns="54864" rIns="54864" tIns="27432" bIns="27432"/>
-          <a:lstStyle/>
-          <a:p>
-            <a:pPr algn="ctr"/>
-            <a:r>
-              <a:rPr sz="950" b="1">
-                <a:solidFill>
-                  <a:srgbClr val="0B2E4F"/>
-                </a:solidFill>
-                <a:latin typeface="Calibri"/>
-              </a:rPr>
-              <a:t>WAN link (emulated)</a:t>
-            </a:r>
-          </a:p>
-          <a:p>
-            <a:pPr algn="ctr"/>
-            <a:r>
-              <a:rPr sz="850" b="0">
-                <a:solidFill>
-                  <a:srgbClr val="333333"/>
-                </a:solidFill>
-                <a:latin typeface="Calibri"/>
-              </a:rPr>
-              <a:t>netem + token bucket, 100 to 20 Mbps, IPv4 and IPv6</a:t>
-            </a:r>
-          </a:p>
-        </p:txBody>
-      </p:sp>
-      <p:cxnSp>
-        <p:nvCxnSpPr>
-          <p:cNvPr id="31" name="Connector 30"/>
-          <p:cNvCxnSpPr/>
-          <p:nvPr/>
-        </p:nvCxnSpPr>
-        <p:spPr>
-          <a:xfrm flipV="1">
-            <a:off x="2103120" y="4315968"/>
-            <a:ext cx="0" cy="146304"/>
-          </a:xfrm>
-          <a:prstGeom prst="line">
-            <a:avLst/>
-          </a:prstGeom>
-          <a:ln w="19050">
-            <a:solidFill>
-              <a:srgbClr val="0B2E4F"/>
-            </a:solidFill>
-            <a:tailEnd type="triangle"/>
-          </a:ln>
-        </p:spPr>
-        <p:style>
-          <a:lnRef idx="2">
-            <a:schemeClr val="accent1"/>
-          </a:lnRef>
-          <a:fillRef idx="0">
-            <a:schemeClr val="accent1"/>
-          </a:fillRef>
-          <a:effectRef idx="1">
-            <a:schemeClr val="accent1"/>
-          </a:effectRef>
-          <a:fontRef idx="minor">
-            <a:schemeClr val="tx1"/>
-          </a:fontRef>
-        </p:style>
-      </p:cxnSp>
+              <a:t>CAKE on WAN and IFB; HTB variant for hard floors</a:t>
+            </a:r>
+          </a:p>
+        </p:txBody>
+      </p:sp>
       <p:cxnSp>
         <p:nvCxnSpPr>
           <p:cNvPr id="32" name="Connector 31"/>
@@ -8546,13 +8393,13 @@
         </p:nvCxnSpPr>
         <p:spPr>
           <a:xfrm>
-            <a:off x="3044952" y="3913632"/>
-            <a:ext cx="91439" cy="0"/>
+            <a:off x="3550602" y="4844821"/>
+            <a:ext cx="91440" cy="0"/>
           </a:xfrm>
           <a:prstGeom prst="line">
             <a:avLst/>
           </a:prstGeom>
-          <a:ln w="19050">
+          <a:ln w="15875">
             <a:solidFill>
               <a:srgbClr val="0B2E4F"/>
             </a:solidFill>
@@ -8582,13 +8429,13 @@
         </p:nvCxnSpPr>
         <p:spPr>
           <a:xfrm>
-            <a:off x="5102352" y="3913632"/>
+            <a:off x="5443410" y="4844821"/>
             <a:ext cx="91440" cy="0"/>
           </a:xfrm>
           <a:prstGeom prst="line">
             <a:avLst/>
           </a:prstGeom>
-          <a:ln w="19050">
+          <a:ln w="15875">
             <a:solidFill>
               <a:srgbClr val="0B2E4F"/>
             </a:solidFill>
@@ -8610,78 +8457,140 @@
           </a:fontRef>
         </p:style>
       </p:cxnSp>
-      <p:cxnSp>
-        <p:nvCxnSpPr>
-          <p:cNvPr id="34" name="Connector 33"/>
-          <p:cNvCxnSpPr/>
+      <p:sp>
+        <p:nvSpPr>
+          <p:cNvPr id="34" name="Rounded Rectangle 33"/>
+          <p:cNvSpPr/>
           <p:nvPr/>
-        </p:nvCxnSpPr>
+        </p:nvSpPr>
         <p:spPr>
           <a:xfrm>
-            <a:off x="6135624" y="4315968"/>
-            <a:ext cx="0" cy="146304"/>
-          </a:xfrm>
-          <a:prstGeom prst="line">
-            <a:avLst/>
+            <a:off x="1749234" y="5402304"/>
+            <a:ext cx="2747772" cy="292607"/>
+          </a:xfrm>
+          <a:prstGeom prst="roundRect">
+            <a:avLst>
+              <a:gd name="adj" fmla="val 10000"/>
+            </a:avLst>
           </a:prstGeom>
-          <a:ln w="19050">
+          <a:solidFill>
+            <a:srgbClr val="FFFFFF"/>
+          </a:solidFill>
+          <a:ln w="9525">
             <a:solidFill>
-              <a:srgbClr val="0B2E4F"/>
+              <a:srgbClr val="008CC8"/>
             </a:solidFill>
-            <a:tailEnd type="triangle"/>
           </a:ln>
+          <a:effectLst/>
         </p:spPr>
         <p:style>
-          <a:lnRef idx="2">
+          <a:lnRef idx="1">
             <a:schemeClr val="accent1"/>
           </a:lnRef>
-          <a:fillRef idx="0">
+          <a:fillRef idx="3">
             <a:schemeClr val="accent1"/>
           </a:fillRef>
-          <a:effectRef idx="1">
+          <a:effectRef idx="2">
             <a:schemeClr val="accent1"/>
           </a:effectRef>
           <a:fontRef idx="minor">
-            <a:schemeClr val="tx1"/>
+            <a:schemeClr val="lt1"/>
           </a:fontRef>
         </p:style>
-      </p:cxnSp>
-      <p:cxnSp>
-        <p:nvCxnSpPr>
-          <p:cNvPr id="35" name="Connector 34"/>
-          <p:cNvCxnSpPr/>
+        <p:txBody>
+          <a:bodyPr rtlCol="0" anchor="ctr" wrap="square" lIns="27432" rIns="27432" tIns="27432" bIns="27432"/>
+          <a:lstStyle/>
+          <a:p>
+            <a:pPr algn="ctr"/>
+            <a:r>
+              <a:rPr sz="800" b="1">
+                <a:solidFill>
+                  <a:srgbClr val="0B2E4F"/>
+                </a:solidFill>
+              </a:rPr>
+              <a:t>Home devices (emulated)</a:t>
+            </a:r>
+          </a:p>
+          <a:p>
+            <a:pPr algn="ctr"/>
+            <a:r>
+              <a:rPr sz="750" b="0">
+                <a:solidFill>
+                  <a:srgbClr val="333333"/>
+                </a:solidFill>
+              </a:rPr>
+              <a:t>laptop on a call, console, 3 TVs, a large download</a:t>
+            </a:r>
+          </a:p>
+        </p:txBody>
+      </p:sp>
+      <p:sp>
+        <p:nvSpPr>
+          <p:cNvPr id="35" name="Rounded Rectangle 34"/>
+          <p:cNvSpPr/>
           <p:nvPr/>
-        </p:nvCxnSpPr>
+        </p:nvSpPr>
         <p:spPr>
           <a:xfrm>
-            <a:off x="4087368" y="2286000"/>
-            <a:ext cx="82295" cy="0"/>
-          </a:xfrm>
-          <a:prstGeom prst="line">
-            <a:avLst/>
+            <a:off x="4588446" y="5402304"/>
+            <a:ext cx="2747772" cy="292607"/>
+          </a:xfrm>
+          <a:prstGeom prst="roundRect">
+            <a:avLst>
+              <a:gd name="adj" fmla="val 10000"/>
+            </a:avLst>
           </a:prstGeom>
-          <a:ln w="19050">
+          <a:solidFill>
+            <a:srgbClr val="FFFFFF"/>
+          </a:solidFill>
+          <a:ln w="9525">
             <a:solidFill>
-              <a:srgbClr val="0B2E4F"/>
+              <a:srgbClr val="008CC8"/>
             </a:solidFill>
-            <a:tailEnd type="triangle"/>
           </a:ln>
+          <a:effectLst/>
         </p:spPr>
         <p:style>
-          <a:lnRef idx="2">
+          <a:lnRef idx="1">
             <a:schemeClr val="accent1"/>
           </a:lnRef>
-          <a:fillRef idx="0">
+          <a:fillRef idx="3">
             <a:schemeClr val="accent1"/>
           </a:fillRef>
-          <a:effectRef idx="1">
+          <a:effectRef idx="2">
             <a:schemeClr val="accent1"/>
           </a:effectRef>
           <a:fontRef idx="minor">
-            <a:schemeClr val="tx1"/>
+            <a:schemeClr val="lt1"/>
           </a:fontRef>
         </p:style>
-      </p:cxnSp>
+        <p:txBody>
+          <a:bodyPr rtlCol="0" anchor="ctr" wrap="square" lIns="27432" rIns="27432" tIns="27432" bIns="27432"/>
+          <a:lstStyle/>
+          <a:p>
+            <a:pPr algn="ctr"/>
+            <a:r>
+              <a:rPr sz="800" b="1">
+                <a:solidFill>
+                  <a:srgbClr val="0B2E4F"/>
+                </a:solidFill>
+              </a:rPr>
+              <a:t>WAN link (emulated)</a:t>
+            </a:r>
+          </a:p>
+          <a:p>
+            <a:pPr algn="ctr"/>
+            <a:r>
+              <a:rPr sz="750" b="0">
+                <a:solidFill>
+                  <a:srgbClr val="333333"/>
+                </a:solidFill>
+              </a:rPr>
+              <a:t>netem + token bucket, 100 to 20 Mbps, IPv4 and IPv6</a:t>
+            </a:r>
+          </a:p>
+        </p:txBody>
+      </p:sp>
       <p:cxnSp>
         <p:nvCxnSpPr>
           <p:cNvPr id="36" name="Connector 35"/>
@@ -8690,13 +8599,13 @@
         </p:nvCxnSpPr>
         <p:spPr>
           <a:xfrm>
-            <a:off x="5586984" y="2286000"/>
-            <a:ext cx="82296" cy="0"/>
+            <a:off x="3123120" y="2696886"/>
+            <a:ext cx="0" cy="319738"/>
           </a:xfrm>
           <a:prstGeom prst="line">
             <a:avLst/>
           </a:prstGeom>
-          <a:ln w="19050">
+          <a:ln w="15875">
             <a:solidFill>
               <a:srgbClr val="0B2E4F"/>
             </a:solidFill>
@@ -8726,13 +8635,13 @@
         </p:nvCxnSpPr>
         <p:spPr>
           <a:xfrm>
-            <a:off x="6931152" y="2834640"/>
-            <a:ext cx="0" cy="676656"/>
+            <a:off x="6672135" y="3766432"/>
+            <a:ext cx="0" cy="840645"/>
           </a:xfrm>
           <a:prstGeom prst="line">
             <a:avLst/>
           </a:prstGeom>
-          <a:ln w="19050">
+          <a:ln w="15875">
             <a:solidFill>
               <a:srgbClr val="0B2E4F"/>
             </a:solidFill>
@@ -8761,14 +8670,14 @@
           <p:nvPr/>
         </p:nvCxnSpPr>
         <p:spPr>
-          <a:xfrm>
-            <a:off x="1883664" y="2834640"/>
-            <a:ext cx="0" cy="137160"/>
+          <a:xfrm flipV="1">
+            <a:off x="2649918" y="5082565"/>
+            <a:ext cx="0" cy="319739"/>
           </a:xfrm>
           <a:prstGeom prst="line">
             <a:avLst/>
           </a:prstGeom>
-          <a:ln w="19050">
+          <a:ln w="15875">
             <a:solidFill>
               <a:srgbClr val="0B2E4F"/>
             </a:solidFill>
@@ -8798,13 +8707,13 @@
         </p:nvCxnSpPr>
         <p:spPr>
           <a:xfrm>
-            <a:off x="2560320" y="1591056"/>
-            <a:ext cx="0" cy="146304"/>
+            <a:off x="6435534" y="5082565"/>
+            <a:ext cx="0" cy="319739"/>
           </a:xfrm>
           <a:prstGeom prst="line">
             <a:avLst/>
           </a:prstGeom>
-          <a:ln w="19050">
+          <a:ln w="15875">
             <a:solidFill>
               <a:srgbClr val="0B2E4F"/>
             </a:solidFill>
@@ -8834,203 +8743,8 @@
         </p:nvSpPr>
         <p:spPr>
           <a:xfrm>
-            <a:off x="274320" y="5047488"/>
-            <a:ext cx="6903720" cy="1298448"/>
-          </a:xfrm>
-          <a:prstGeom prst="rect">
-            <a:avLst/>
-          </a:prstGeom>
-          <a:solidFill>
-            <a:srgbClr val="FFFFFF"/>
-          </a:solidFill>
-          <a:ln w="12700">
-            <a:solidFill>
-              <a:srgbClr val="008CC8"/>
-            </a:solidFill>
-          </a:ln>
-          <a:effectLst/>
-        </p:spPr>
-        <p:style>
-          <a:lnRef idx="1">
-            <a:schemeClr val="accent1"/>
-          </a:lnRef>
-          <a:fillRef idx="3">
-            <a:schemeClr val="accent1"/>
-          </a:fillRef>
-          <a:effectRef idx="2">
-            <a:schemeClr val="accent1"/>
-          </a:effectRef>
-          <a:fontRef idx="minor">
-            <a:schemeClr val="lt1"/>
-          </a:fontRef>
-        </p:style>
-        <p:txBody>
-          <a:bodyPr rtlCol="0" anchor="t" wrap="square" lIns="54864" rIns="54864" tIns="27432" bIns="27432"/>
-          <a:lstStyle/>
-          <a:p>
-            <a:pPr algn="l">
-              <a:spcAft>
-                <a:spcPts val="400"/>
-              </a:spcAft>
-            </a:pPr>
-            <a:r>
-              <a:rPr sz="1000" b="1">
-                <a:solidFill>
-                  <a:srgbClr val="008CC8"/>
-                </a:solidFill>
-                <a:latin typeface="Calibri"/>
-              </a:rPr>
-              <a:t>Key design decisions</a:t>
-            </a:r>
-          </a:p>
-          <a:p>
-            <a:pPr algn="l">
-              <a:spcAft>
-                <a:spcPts val="400"/>
-              </a:spcAft>
-            </a:pPr>
-            <a:r>
-              <a:rPr sz="1000" b="1">
-                <a:solidFill>
-                  <a:srgbClr val="008CC8"/>
-                </a:solidFill>
-                <a:latin typeface="Calibri"/>
-              </a:rPr>
-              <a:t>• </a:t>
-            </a:r>
-            <a:r>
-              <a:rPr sz="1000" b="1">
-                <a:solidFill>
-                  <a:srgbClr val="0B2E4F"/>
-                </a:solidFill>
-                <a:latin typeface="Calibri"/>
-              </a:rPr>
-              <a:t>Tins: </a:t>
-            </a:r>
-            <a:r>
-              <a:rPr sz="1000" b="0">
-                <a:solidFill>
-                  <a:srgbClr val="333333"/>
-                </a:solidFill>
-                <a:latin typeface="Calibri"/>
-              </a:rPr>
-              <a:t>call audio and games go to the Voice tin, call video to the Video tin (Voice is capped at 25% in diffserv4)</a:t>
-            </a:r>
-          </a:p>
-          <a:p>
-            <a:pPr algn="l">
-              <a:spcAft>
-                <a:spcPts val="400"/>
-              </a:spcAft>
-            </a:pPr>
-            <a:r>
-              <a:rPr sz="1000" b="1">
-                <a:solidFill>
-                  <a:srgbClr val="008CC8"/>
-                </a:solidFill>
-                <a:latin typeface="Calibri"/>
-              </a:rPr>
-              <a:t>• </a:t>
-            </a:r>
-            <a:r>
-              <a:rPr sz="1000" b="1">
-                <a:solidFill>
-                  <a:srgbClr val="0B2E4F"/>
-                </a:solidFill>
-                <a:latin typeface="Calibri"/>
-              </a:rPr>
-              <a:t>Trust: </a:t>
-            </a:r>
-            <a:r>
-              <a:rPr sz="1000" b="0">
-                <a:solidFill>
-                  <a:srgbClr val="333333"/>
-                </a:solidFill>
-                <a:latin typeface="Calibri"/>
-              </a:rPr>
-              <a:t>DSCP marks coming from the Internet are cleared, so outside traffic cannot claim priority</a:t>
-            </a:r>
-          </a:p>
-          <a:p>
-            <a:pPr algn="l">
-              <a:spcAft>
-                <a:spcPts val="400"/>
-              </a:spcAft>
-            </a:pPr>
-            <a:r>
-              <a:rPr sz="1000" b="1">
-                <a:solidFill>
-                  <a:srgbClr val="008CC8"/>
-                </a:solidFill>
-                <a:latin typeface="Calibri"/>
-              </a:rPr>
-              <a:t>• </a:t>
-            </a:r>
-            <a:r>
-              <a:rPr sz="1000" b="1">
-                <a:solidFill>
-                  <a:srgbClr val="0B2E4F"/>
-                </a:solidFill>
-                <a:latin typeface="Calibri"/>
-              </a:rPr>
-              <a:t>Two loops: </a:t>
-            </a:r>
-            <a:r>
-              <a:rPr sz="1000" b="0">
-                <a:solidFill>
-                  <a:srgbClr val="333333"/>
-                </a:solidFill>
-                <a:latin typeface="Calibri"/>
-              </a:rPr>
-              <a:t>a speed drop is handled within a second; policy changes go through the safety check</a:t>
-            </a:r>
-          </a:p>
-          <a:p>
-            <a:pPr algn="l">
-              <a:spcAft>
-                <a:spcPts val="400"/>
-              </a:spcAft>
-            </a:pPr>
-            <a:r>
-              <a:rPr sz="1000" b="1">
-                <a:solidFill>
-                  <a:srgbClr val="008CC8"/>
-                </a:solidFill>
-                <a:latin typeface="Calibri"/>
-              </a:rPr>
-              <a:t>• </a:t>
-            </a:r>
-            <a:r>
-              <a:rPr sz="1000" b="1">
-                <a:solidFill>
-                  <a:srgbClr val="0B2E4F"/>
-                </a:solidFill>
-                <a:latin typeface="Calibri"/>
-              </a:rPr>
-              <a:t>Privacy: </a:t>
-            </a:r>
-            <a:r>
-              <a:rPr sz="1000" b="0">
-                <a:solidFill>
-                  <a:srgbClr val="333333"/>
-                </a:solidFill>
-                <a:latin typeface="Calibri"/>
-              </a:rPr>
-              <a:t>no payload or domain logging; the intent API is LAN-only and needs a token</a:t>
-            </a:r>
-          </a:p>
-        </p:txBody>
-      </p:sp>
-      <p:sp>
-        <p:nvSpPr>
-          <p:cNvPr id="41" name="Rectangle 40"/>
-          <p:cNvSpPr/>
-          <p:nvPr/>
-        </p:nvSpPr>
-        <p:spPr>
-          <a:xfrm>
-            <a:off x="7360920" y="822960"/>
-            <a:ext cx="4553712" cy="329184"/>
+            <a:off x="7509954" y="2358558"/>
+            <a:ext cx="4023360" cy="256032"/>
           </a:xfrm>
           <a:prstGeom prst="rect">
             <a:avLst/>
@@ -9058,16 +8772,15 @@
           </a:fontRef>
         </p:style>
         <p:txBody>
-          <a:bodyPr rtlCol="0" anchor="ctr" wrap="square" lIns="54864" rIns="54864" tIns="27432" bIns="27432"/>
+          <a:bodyPr rtlCol="0" anchor="ctr" wrap="square" lIns="45720" rIns="45720" tIns="27432" bIns="27432"/>
           <a:lstStyle/>
           <a:p>
             <a:pPr algn="ctr"/>
             <a:r>
-              <a:rPr sz="1050" b="1">
+              <a:rPr sz="900" b="1">
                 <a:solidFill>
                   <a:srgbClr val="FFFFFF"/>
                 </a:solidFill>
-                <a:latin typeface="Calibri"/>
               </a:rPr>
               <a:t>Where we use ML, and how we check it helps</a:t>
             </a:r>
@@ -9076,14 +8789,14 @@
       </p:sp>
       <p:sp>
         <p:nvSpPr>
-          <p:cNvPr id="42" name="Rectangle 41"/>
+          <p:cNvPr id="41" name="Rectangle 40"/>
           <p:cNvSpPr/>
           <p:nvPr/>
         </p:nvSpPr>
         <p:spPr>
           <a:xfrm>
-            <a:off x="7360920" y="1152144"/>
-            <a:ext cx="4553712" cy="2670048"/>
+            <a:off x="7509954" y="2614590"/>
+            <a:ext cx="4023360" cy="1755648"/>
           </a:xfrm>
           <a:prstGeom prst="rect">
             <a:avLst/>
@@ -9091,7 +8804,7 @@
           <a:solidFill>
             <a:srgbClr val="FFFFFF"/>
           </a:solidFill>
-          <a:ln w="12700">
+          <a:ln w="9525">
             <a:solidFill>
               <a:srgbClr val="2B6CB0"/>
             </a:solidFill>
@@ -9113,7 +8826,7 @@
           </a:fontRef>
         </p:style>
         <p:txBody>
-          <a:bodyPr rtlCol="0" anchor="t" wrap="square" lIns="54864" rIns="54864" tIns="27432" bIns="27432"/>
+          <a:bodyPr rtlCol="0" anchor="t" wrap="square" lIns="45720" rIns="45720" tIns="27432" bIns="27432"/>
           <a:lstStyle/>
           <a:p>
             <a:pPr algn="l">
@@ -9122,31 +8835,28 @@
               </a:spcAft>
             </a:pPr>
             <a:r>
-              <a:rPr sz="1050" b="1">
+              <a:rPr sz="880" b="1">
                 <a:solidFill>
                   <a:srgbClr val="2B6CB0"/>
                 </a:solidFill>
-                <a:latin typeface="Calibri"/>
               </a:rPr>
               <a:t>1. Flow classifier: </a:t>
             </a:r>
             <a:r>
-              <a:rPr sz="1050" b="0">
+              <a:rPr sz="880" b="0">
                 <a:solidFill>
                   <a:srgbClr val="333333"/>
                 </a:solidFill>
-                <a:latin typeface="Calibri"/>
               </a:rPr>
-              <a:t>LightGBM on flow features with conformal prediction. A flow is prioritised only when the model is confident, which keeps wrong boosts under a target rate (say 1%). </a:t>
-            </a:r>
-            <a:r>
-              <a:rPr sz="1050" b="1">
+              <a:t>LightGBM with conformal prediction. A flow is prioritised only when the model is confident, keeping wrong boosts under a target rate (say 1%). </a:t>
+            </a:r>
+            <a:r>
+              <a:rPr sz="880" b="1">
                 <a:solidFill>
                   <a:srgbClr val="0B2E4F"/>
                 </a:solidFill>
-                <a:latin typeface="Calibri"/>
               </a:rPr>
-              <a:t>Compared with port-based rules.</a:t>
+              <a:t>Compared with port rules.</a:t>
             </a:r>
           </a:p>
           <a:p>
@@ -9156,31 +8866,28 @@
               </a:spcAft>
             </a:pPr>
             <a:r>
-              <a:rPr sz="1050" b="1">
+              <a:rPr sz="880" b="1">
                 <a:solidFill>
                   <a:srgbClr val="2B6CB0"/>
                 </a:solidFill>
-                <a:latin typeface="Calibri"/>
               </a:rPr>
               <a:t>2. Link model: </a:t>
             </a:r>
             <a:r>
-              <a:rPr sz="1050" b="0">
+              <a:rPr sz="880" b="0">
                 <a:solidFill>
                   <a:srgbClr val="333333"/>
                 </a:solidFill>
-                <a:latin typeface="Calibri"/>
               </a:rPr>
-              <a:t>trained offline on lab runs, it predicts how a policy change will affect call delay, so risky changes are dropped before the live trial. </a:t>
-            </a:r>
-            <a:r>
-              <a:rPr sz="1050" b="1">
+              <a:t>trained offline on lab runs; predicts how a policy change affects call delay, so risky changes are dropped before the live trial. </a:t>
+            </a:r>
+            <a:r>
+              <a:rPr sz="880" b="1">
                 <a:solidFill>
                   <a:srgbClr val="0B2E4F"/>
                 </a:solidFill>
-                <a:latin typeface="Calibri"/>
               </a:rPr>
-              <a:t>Measured by seconds of bad call delay avoided.</a:t>
+              <a:t>Measured by bad-delay seconds avoided.</a:t>
             </a:r>
           </a:p>
           <a:p>
@@ -9190,31 +8897,28 @@
               </a:spcAft>
             </a:pPr>
             <a:r>
-              <a:rPr sz="1050" b="1">
+              <a:rPr sz="880" b="1">
                 <a:solidFill>
                   <a:srgbClr val="2B6CB0"/>
                 </a:solidFill>
-                <a:latin typeface="Calibri"/>
               </a:rPr>
               <a:t>3. Auto-protect: </a:t>
             </a:r>
             <a:r>
-              <a:rPr sz="1050" b="0">
+              <a:rPr sz="880" b="0">
                 <a:solidFill>
                   <a:srgbClr val="333333"/>
                 </a:solidFill>
-                <a:latin typeface="Calibri"/>
               </a:rPr>
-              <a:t>when a call starts on a busy link it is protected automatically, within a daily per-device limit, and the user can undo it. </a:t>
-            </a:r>
-            <a:r>
-              <a:rPr sz="1050" b="1">
+              <a:t>a call starting on a busy link is protected automatically, within a daily per-device limit, with undo. </a:t>
+            </a:r>
+            <a:r>
+              <a:rPr sz="880" b="1">
                 <a:solidFill>
                   <a:srgbClr val="0B2E4F"/>
                 </a:solidFill>
-                <a:latin typeface="Calibri"/>
               </a:rPr>
-              <a:t>Measured by time from call start to protection.</a:t>
+              <a:t>Measured by time to protection.</a:t>
             </a:r>
           </a:p>
           <a:p>
@@ -9224,27 +8928,26 @@
               </a:spcAft>
             </a:pPr>
             <a:r>
-              <a:rPr sz="1050" b="0">
+              <a:rPr sz="880" b="0">
                 <a:solidFill>
                   <a:srgbClr val="333333"/>
                 </a:solidFill>
-                <a:latin typeface="Calibri"/>
               </a:rPr>
-              <a:t>Each ML part is tested against the plain rule-based version. If it does not improve the numbers, we drop it.</a:t>
-            </a:r>
-          </a:p>
-        </p:txBody>
-      </p:sp>
-      <p:sp>
-        <p:nvSpPr>
-          <p:cNvPr id="43" name="Rectangle 42"/>
+              <a:t>Each ML part is tested against the rule-based version. If it does not improve the numbers, we drop it.</a:t>
+            </a:r>
+          </a:p>
+        </p:txBody>
+      </p:sp>
+      <p:sp>
+        <p:nvSpPr>
+          <p:cNvPr id="42" name="Rectangle 41"/>
           <p:cNvSpPr/>
           <p:nvPr/>
         </p:nvSpPr>
         <p:spPr>
           <a:xfrm>
-            <a:off x="7360920" y="3913632"/>
-            <a:ext cx="4553712" cy="292608"/>
+            <a:off x="7509954" y="4461678"/>
+            <a:ext cx="4023360" cy="256032"/>
           </a:xfrm>
           <a:prstGeom prst="rect">
             <a:avLst/>
@@ -9272,16 +8975,15 @@
           </a:fontRef>
         </p:style>
         <p:txBody>
-          <a:bodyPr rtlCol="0" anchor="ctr" wrap="square" lIns="54864" rIns="54864" tIns="27432" bIns="27432"/>
+          <a:bodyPr rtlCol="0" anchor="ctr" wrap="square" lIns="45720" rIns="45720" tIns="27432" bIns="27432"/>
           <a:lstStyle/>
           <a:p>
             <a:pPr algn="ctr"/>
             <a:r>
-              <a:rPr sz="1050" b="1">
+              <a:rPr sz="900" b="1">
                 <a:solidFill>
                   <a:srgbClr val="F5B400"/>
                 </a:solidFill>
-                <a:latin typeface="Calibri"/>
               </a:rPr>
               <a:t>Early test we ran (27 Oct)</a:t>
             </a:r>
@@ -9290,14 +8992,14 @@
       </p:sp>
       <p:sp>
         <p:nvSpPr>
-          <p:cNvPr id="44" name="Rectangle 43"/>
+          <p:cNvPr id="43" name="Rectangle 42"/>
           <p:cNvSpPr/>
           <p:nvPr/>
         </p:nvSpPr>
         <p:spPr>
           <a:xfrm>
-            <a:off x="7360920" y="4206240"/>
-            <a:ext cx="4553712" cy="2139696"/>
+            <a:off x="7509954" y="4717710"/>
+            <a:ext cx="4023360" cy="1992186"/>
           </a:xfrm>
           <a:prstGeom prst="rect">
             <a:avLst/>
@@ -9305,7 +9007,7 @@
           <a:solidFill>
             <a:srgbClr val="FFFFFF"/>
           </a:solidFill>
-          <a:ln w="12700">
+          <a:ln w="9525">
             <a:solidFill>
               <a:srgbClr val="0B2E4F"/>
             </a:solidFill>
@@ -9336,15 +9038,15 @@
       </p:sp>
       <p:graphicFrame>
         <p:nvGraphicFramePr>
-          <p:cNvPr id="45" name="Chart 44"/>
+          <p:cNvPr id="44" name="Chart 43"/>
           <p:cNvGraphicFramePr>
             <a:graphicFrameLocks noGrp="1"/>
           </p:cNvGraphicFramePr>
           <p:nvPr/>
         </p:nvGraphicFramePr>
         <p:xfrm>
-          <a:off x="7406640" y="4224528"/>
-          <a:ext cx="4462272" cy="1097280"/>
+          <a:off x="7537386" y="4735998"/>
+          <a:ext cx="3968496" cy="1051560"/>
         </p:xfrm>
         <a:graphic>
           <a:graphicData uri="http://schemas.openxmlformats.org/drawingml/2006/chart">
@@ -9354,14 +9056,14 @@
       </p:graphicFrame>
       <p:sp>
         <p:nvSpPr>
-          <p:cNvPr id="46" name="TextBox 45"/>
+          <p:cNvPr id="45" name="TextBox 44"/>
           <p:cNvSpPr txBox="1"/>
           <p:nvPr/>
         </p:nvSpPr>
         <p:spPr>
           <a:xfrm>
-            <a:off x="7406640" y="5303520"/>
-            <a:ext cx="4462272" cy="1024128"/>
+            <a:off x="7537386" y="5787558"/>
+            <a:ext cx="3968496" cy="904050"/>
           </a:xfrm>
           <a:prstGeom prst="rect">
             <a:avLst/>
@@ -9369,85 +9071,38 @@
           <a:noFill/>
         </p:spPr>
         <p:txBody>
-          <a:bodyPr wrap="square" anchor="t" lIns="54864" rIns="54864" tIns="27432" bIns="27432">
+          <a:bodyPr wrap="square" anchor="t" lIns="45720" rIns="45720" tIns="27432" bIns="27432">
             <a:spAutoFit/>
           </a:bodyPr>
           <a:lstStyle/>
           <a:p>
             <a:pPr algn="l"/>
             <a:r>
-              <a:rPr sz="900" b="1">
+              <a:rPr sz="750" b="1">
                 <a:solidFill>
                   <a:srgbClr val="0B2E4F"/>
                 </a:solidFill>
-                <a:latin typeface="Calibri"/>
               </a:rPr>
-              <a:t>Download speed was the same in both cases </a:t>
-            </a:r>
-            <a:r>
-              <a:rPr sz="900" b="0">
+              <a:t>Same download speed in both </a:t>
+            </a:r>
+            <a:r>
+              <a:rPr sz="750" b="0">
                 <a:solidFill>
                   <a:srgbClr val="333333"/>
                 </a:solidFill>
-                <a:latin typeface="Calibri"/>
               </a:rPr>
-              <a:t>(18.7 of 20 Mbps), so the call was protected without starving the download.</a:t>
+              <a:t>(18.7 of 20 Mbps): the call was protected without starving the download.</a:t>
             </a:r>
           </a:p>
           <a:p>
             <a:pPr algn="l"/>
             <a:r>
-              <a:rPr sz="900" b="0">
+              <a:rPr sz="750" b="0">
                 <a:solidFill>
                   <a:srgbClr val="333333"/>
                 </a:solidFill>
-                <a:latin typeface="Calibri"/>
               </a:rPr>
-              <a:t>Setup: 2 Linux namespaces, 20 Mbit link, 4 TCP streams, 50 pings/s, 5 runs each. No WAN delay was emulated. In Round 2 we will compare against CAKE, CAKE autorate and cake-autorate across 14 scenarios.</a:t>
-            </a:r>
-          </a:p>
-        </p:txBody>
-      </p:sp>
-      <p:sp>
-        <p:nvSpPr>
-          <p:cNvPr id="47" name="TextBox 46"/>
-          <p:cNvSpPr txBox="1"/>
-          <p:nvPr/>
-        </p:nvSpPr>
-        <p:spPr>
-          <a:xfrm>
-            <a:off x="274320" y="6400800"/>
-            <a:ext cx="11640312" cy="365760"/>
-          </a:xfrm>
-          <a:prstGeom prst="rect">
-            <a:avLst/>
-          </a:prstGeom>
-          <a:noFill/>
-        </p:spPr>
-        <p:txBody>
-          <a:bodyPr wrap="square" anchor="t" lIns="54864" rIns="54864" tIns="27432" bIns="27432">
-            <a:spAutoFit/>
-          </a:bodyPr>
-          <a:lstStyle/>
-          <a:p>
-            <a:pPr algn="ctr"/>
-            <a:r>
-              <a:rPr sz="900" b="1">
-                <a:solidFill>
-                  <a:srgbClr val="0B2E4F"/>
-                </a:solidFill>
-                <a:latin typeface="Calibri"/>
-              </a:rPr>
-              <a:t>Scope: </a:t>
-            </a:r>
-            <a:r>
-              <a:rPr sz="900" b="0">
-                <a:solidFill>
-                  <a:srgbClr val="333333"/>
-                </a:solidFill>
-                <a:latin typeface="Calibri"/>
-              </a:rPr>
-              <a:t>the prototype runs in emulation. A real router would also need hardware offload handling, enough CPU for gigabit shaping, and Wi-Fi airtime fairness.</a:t>
+              <a:t>2 Linux namespaces, 20 Mbit link, 4 TCP streams, 50 pings/s, 5 runs each, no WAN delay. Round 2 compares against CAKE, CAKE autorate and cake-autorate in 14 scenarios.</a:t>
             </a:r>
           </a:p>
         </p:txBody>

</xml_diff>